<commit_message>
Week 4 Wednesday: the heavy-buyer trap gets its prediction
S33's notes ask the room where chips and cold drink's 3.39 lands with every customer
counted once before S34 shows it, and notebook 03 asks the same before the cell runs and
says what happened after it, so every trap has a predict step in the deck and the
notebook.

Co-Authored-By: Claude Opus 5.5 <noreply@anthropic.com>
Claude-Session: https://claude.ai/code/session_01NN5zp6kMYG3SQZMpC3fcxc
</commit_message>
<xml_diff>
--- a/content/W04/D3/slides/C2_W04_D03_half1_STUDENT.pptx
+++ b/content/W04/D3/slides/C2_W04_D03_half1_STUDENT.pptx
@@ -2866,7 +2866,22 @@
           </a:p>
           <a:p>
             <a:r>
-              <a:t>add falls by the discount. Transition: what the counts cannot tell us.</a:t>
+              <a:t>add falls by the discount. Then, before S34, the prediction for its heavy-buyer row: the top tenth of</a:t>
+            </a:r>
+          </a:p>
+          <a:p>
+            <a:r>
+              <a:t>customers place 38 percent of carts; with every customer counted once, does chips and cold drink's</a:t>
+            </a:r>
+          </a:p>
+          <a:p>
+            <a:r>
+              <a:t>3.39 stay above 3, fall to about 2.5, or fall to about one? Hands up, then S34. Transition: what the</a:t>
+            </a:r>
+          </a:p>
+          <a:p>
+            <a:r>
+              <a:t>counts cannot tell us.</a:t>
             </a:r>
           </a:p>
         </p:txBody>

</xml_diff>